<commit_message>
pptx: tone latency line
</commit_message>
<xml_diff>
--- a/pitch/I-Missed-That-BAINSA.pptx
+++ b/pitch/I-Missed-That-BAINSA.pptx
@@ -775,7 +775,7 @@
           <a:p>
             <a:r>
               <a:rPr lang="en-US" dirty="0"/>
-              <a:t>Sentence under 1 second. Lamp under 2 seconds. Nothing is stored.
+              <a:t>Sentence under 1 second. Tone in 0.7 s. Lamp under 2 seconds. Nothing is stored.
 Q9: What if Deepgram is down mid-demo? ?replay= needs neither key nor mic and reproduces the exact same cards deterministically.</a:t>
             </a:r>
             <a:endParaRPr lang="en-US" dirty="0"/>
@@ -3337,7 +3337,7 @@
                 <a:ea typeface="Arial" pitchFamily="34" charset="-122"/>
                 <a:cs typeface="Arial" pitchFamily="34" charset="-120"/>
               </a:rPr>
-              <a:t>Sentence under 1 second. Lamp under 2 seconds. </a:t>
+              <a:t>Sentence under 1 second. Tone in 0.7 s. Lamp under 2 seconds. </a:t>
             </a:r>
             <a:pPr indent="0" marL="0">
               <a:buNone/>

</xml_diff>